<commit_message>
docs: refresh solution and overview deck
</commit_message>
<xml_diff>
--- a/docs/business-overview-deck/output/bill_verification_business_overview.pptx
+++ b/docs/business-overview-deck/output/bill_verification_business_overview.pptx
@@ -12,6 +12,7 @@
     <p:sldId id="260" r:id="rId11"/>
     <p:sldId id="261" r:id="rId12"/>
     <p:sldId id="262" r:id="rId13"/>
+    <p:sldId id="263" r:id="rId14"/>
   </p:sldIdLst>
   <p:sldSz cx="14630400" cy="8229600" type="screen4x3"/>
   <p:notesSz cx="6858000" cy="9144000"/>
@@ -3141,7 +3142,7 @@
           <a:lstStyle/>
           <a:p>
             <a:pPr>
-              <a:defRPr sz="800" b="0">
+              <a:defRPr sz="800">
                 <a:solidFill>
                   <a:srgbClr val="7A8795"/>
                 </a:solidFill>
@@ -3219,7 +3220,7 @@
           <a:lstStyle/>
           <a:p>
             <a:pPr>
-              <a:defRPr sz="800" b="0">
+              <a:defRPr sz="800">
                 <a:solidFill>
                   <a:srgbClr val="7A8795"/>
                 </a:solidFill>
@@ -3297,7 +3298,7 @@
           <a:lstStyle/>
           <a:p>
             <a:pPr>
-              <a:defRPr sz="800" b="0">
+              <a:defRPr sz="800">
                 <a:solidFill>
                   <a:srgbClr val="7A8795"/>
                 </a:solidFill>
@@ -3375,7 +3376,7 @@
           <a:lstStyle/>
           <a:p>
             <a:pPr>
-              <a:defRPr sz="800" b="0">
+              <a:defRPr sz="800">
                 <a:solidFill>
                   <a:srgbClr val="7A8795"/>
                 </a:solidFill>
@@ -3453,7 +3454,7 @@
           <a:lstStyle/>
           <a:p>
             <a:pPr>
-              <a:defRPr sz="800" b="0">
+              <a:defRPr sz="800">
                 <a:solidFill>
                   <a:srgbClr val="7A8795"/>
                 </a:solidFill>
@@ -3531,7 +3532,7 @@
           <a:lstStyle/>
           <a:p>
             <a:pPr>
-              <a:defRPr sz="800" b="0">
+              <a:defRPr sz="800">
                 <a:solidFill>
                   <a:srgbClr val="7A8795"/>
                 </a:solidFill>
@@ -3609,7 +3610,7 @@
           <a:lstStyle/>
           <a:p>
             <a:pPr>
-              <a:defRPr sz="800" b="0">
+              <a:defRPr sz="800">
                 <a:solidFill>
                   <a:srgbClr val="7A8795"/>
                 </a:solidFill>
@@ -3618,6 +3619,84 @@
             </a:pPr>
             <a:r>
               <a:t>权签票据一致性 AI 预审 - 第 7 页</a:t>
+            </a:r>
+          </a:p>
+        </p:txBody>
+      </p:sp>
+    </p:spTree>
+  </p:cSld>
+  <p:clrMapOvr>
+    <a:masterClrMapping/>
+  </p:clrMapOvr>
+</p:sld>
+</file>
+
+<file path=ppt/slides/slide8.xml><?xml version="1.0" encoding="utf-8"?>
+<p:sld xmlns:a="http://schemas.openxmlformats.org/drawingml/2006/main" xmlns:p="http://schemas.openxmlformats.org/presentationml/2006/main" xmlns:r="http://schemas.openxmlformats.org/officeDocument/2006/relationships">
+  <p:cSld>
+    <p:spTree>
+      <p:nvGrpSpPr>
+        <p:cNvPr id="1" name=""/>
+        <p:cNvGrpSpPr/>
+        <p:nvPr/>
+      </p:nvGrpSpPr>
+      <p:grpSpPr/>
+      <p:pic>
+        <p:nvPicPr>
+          <p:cNvPr id="2" name="Picture 1" descr="slide_08.png"/>
+          <p:cNvPicPr>
+            <a:picLocks noChangeAspect="1"/>
+          </p:cNvPicPr>
+          <p:nvPr/>
+        </p:nvPicPr>
+        <p:blipFill>
+          <a:blip r:embed="rId2"/>
+          <a:stretch>
+            <a:fillRect/>
+          </a:stretch>
+        </p:blipFill>
+        <p:spPr>
+          <a:xfrm>
+            <a:off x="0" y="0"/>
+            <a:ext cx="14630400" cy="8229600"/>
+          </a:xfrm>
+          <a:prstGeom prst="rect">
+            <a:avLst/>
+          </a:prstGeom>
+        </p:spPr>
+      </p:pic>
+      <p:sp>
+        <p:nvSpPr>
+          <p:cNvPr id="3" name="TextBox 2"/>
+          <p:cNvSpPr txBox="1"/>
+          <p:nvPr/>
+        </p:nvSpPr>
+        <p:spPr>
+          <a:xfrm>
+            <a:off x="137160" y="7818120"/>
+            <a:ext cx="5486400" cy="274320"/>
+          </a:xfrm>
+          <a:prstGeom prst="rect">
+            <a:avLst/>
+          </a:prstGeom>
+          <a:noFill/>
+        </p:spPr>
+        <p:txBody>
+          <a:bodyPr wrap="none">
+            <a:spAutoFit/>
+          </a:bodyPr>
+          <a:lstStyle/>
+          <a:p>
+            <a:pPr>
+              <a:defRPr sz="800">
+                <a:solidFill>
+                  <a:srgbClr val="7A8795"/>
+                </a:solidFill>
+                <a:latin typeface="Microsoft YaHei"/>
+              </a:defRPr>
+            </a:pPr>
+            <a:r>
+              <a:t>权签票据一致性 AI 预审 - 第 8 页</a:t>
             </a:r>
           </a:p>
         </p:txBody>

</xml_diff>

<commit_message>
feat: clarify extraction risks and workflow materials
</commit_message>
<xml_diff>
--- a/docs/business-overview-deck/output/bill_verification_business_overview.pptx
+++ b/docs/business-overview-deck/output/bill_verification_business_overview.pptx
@@ -13,6 +13,7 @@
     <p:sldId id="261" r:id="rId12"/>
     <p:sldId id="262" r:id="rId13"/>
     <p:sldId id="263" r:id="rId14"/>
+    <p:sldId id="264" r:id="rId15"/>
   </p:sldIdLst>
   <p:sldSz cx="14630400" cy="8229600" type="screen4x3"/>
   <p:notesSz cx="6858000" cy="9144000"/>
@@ -3697,6 +3698,84 @@
             </a:pPr>
             <a:r>
               <a:t>权签票据一致性 AI 预审 - 第 8 页</a:t>
+            </a:r>
+          </a:p>
+        </p:txBody>
+      </p:sp>
+    </p:spTree>
+  </p:cSld>
+  <p:clrMapOvr>
+    <a:masterClrMapping/>
+  </p:clrMapOvr>
+</p:sld>
+</file>
+
+<file path=ppt/slides/slide9.xml><?xml version="1.0" encoding="utf-8"?>
+<p:sld xmlns:a="http://schemas.openxmlformats.org/drawingml/2006/main" xmlns:p="http://schemas.openxmlformats.org/presentationml/2006/main" xmlns:r="http://schemas.openxmlformats.org/officeDocument/2006/relationships">
+  <p:cSld>
+    <p:spTree>
+      <p:nvGrpSpPr>
+        <p:cNvPr id="1" name=""/>
+        <p:cNvGrpSpPr/>
+        <p:nvPr/>
+      </p:nvGrpSpPr>
+      <p:grpSpPr/>
+      <p:pic>
+        <p:nvPicPr>
+          <p:cNvPr id="2" name="Picture 1" descr="slide_09.png"/>
+          <p:cNvPicPr>
+            <a:picLocks noChangeAspect="1"/>
+          </p:cNvPicPr>
+          <p:nvPr/>
+        </p:nvPicPr>
+        <p:blipFill>
+          <a:blip r:embed="rId2"/>
+          <a:stretch>
+            <a:fillRect/>
+          </a:stretch>
+        </p:blipFill>
+        <p:spPr>
+          <a:xfrm>
+            <a:off x="0" y="0"/>
+            <a:ext cx="14630400" cy="8229600"/>
+          </a:xfrm>
+          <a:prstGeom prst="rect">
+            <a:avLst/>
+          </a:prstGeom>
+        </p:spPr>
+      </p:pic>
+      <p:sp>
+        <p:nvSpPr>
+          <p:cNvPr id="3" name="TextBox 2"/>
+          <p:cNvSpPr txBox="1"/>
+          <p:nvPr/>
+        </p:nvSpPr>
+        <p:spPr>
+          <a:xfrm>
+            <a:off x="137160" y="7818120"/>
+            <a:ext cx="5486400" cy="274320"/>
+          </a:xfrm>
+          <a:prstGeom prst="rect">
+            <a:avLst/>
+          </a:prstGeom>
+          <a:noFill/>
+        </p:spPr>
+        <p:txBody>
+          <a:bodyPr wrap="none">
+            <a:spAutoFit/>
+          </a:bodyPr>
+          <a:lstStyle/>
+          <a:p>
+            <a:pPr>
+              <a:defRPr sz="800">
+                <a:solidFill>
+                  <a:srgbClr val="7A8795"/>
+                </a:solidFill>
+                <a:latin typeface="Microsoft YaHei"/>
+              </a:defRPr>
+            </a:pPr>
+            <a:r>
+              <a:t>权签票据一致性 AI 预审 - 第 9 页</a:t>
             </a:r>
           </a:p>
         </p:txBody>

</xml_diff>